<commit_message>
Deck review: fix slide 2 card overflow and chart label overlaps
The S$10,000 card text ran past its card; the curve's 'raw 140' label hit
the Critical band label; the '+5 per hour' note sat on the 62/65 labels.

Co-Authored-By: Claude Opus 5.5 (1M context) <noreply@anthropic.com>
Claude-Session: https://claude.ai/code/session_01PajoehdHSE8Sj3N8MvuS8X
</commit_message>
<xml_diff>
--- a/mvp/deck/CactAI.pptx
+++ b/mvp/deck/CactAI.pptx
@@ -6711,7 +6711,7 @@
         <p:spPr>
           <a:xfrm>
             <a:off x="640080" y="1920240"/>
-            <a:ext cx="2560320" cy="2103120"/>
+            <a:ext cx="2560320" cy="2286000"/>
           </a:xfrm>
           <a:prstGeom prst="roundRect">
             <a:avLst>
@@ -6798,7 +6798,7 @@
         <p:spPr>
           <a:xfrm>
             <a:off x="868680" y="2880360"/>
-            <a:ext cx="2103120" cy="1005840"/>
+            <a:ext cx="2103120" cy="1188720"/>
           </a:xfrm>
           <a:prstGeom prst="rect">
             <a:avLst/>
@@ -6817,7 +6817,7 @@
               </a:lnSpc>
             </a:pPr>
             <a:r>
-              <a:rPr sz="1700" b="0">
+              <a:rPr sz="1600" b="0">
                 <a:solidFill>
                   <a:srgbClr val="F2F5F3"/>
                 </a:solidFill>
@@ -6837,7 +6837,7 @@
         <p:spPr>
           <a:xfrm>
             <a:off x="3410712" y="1920240"/>
-            <a:ext cx="2560320" cy="2103120"/>
+            <a:ext cx="2560320" cy="2286000"/>
           </a:xfrm>
           <a:prstGeom prst="roundRect">
             <a:avLst>
@@ -6924,7 +6924,7 @@
         <p:spPr>
           <a:xfrm>
             <a:off x="3639312" y="2880360"/>
-            <a:ext cx="2103120" cy="1005840"/>
+            <a:ext cx="2103120" cy="1188720"/>
           </a:xfrm>
           <a:prstGeom prst="rect">
             <a:avLst/>
@@ -6943,7 +6943,7 @@
               </a:lnSpc>
             </a:pPr>
             <a:r>
-              <a:rPr sz="1700" b="0">
+              <a:rPr sz="1600" b="0">
                 <a:solidFill>
                   <a:srgbClr val="F2F5F3"/>
                 </a:solidFill>
@@ -6963,7 +6963,7 @@
         <p:spPr>
           <a:xfrm>
             <a:off x="6181344" y="1920240"/>
-            <a:ext cx="2560320" cy="2103120"/>
+            <a:ext cx="2560320" cy="2286000"/>
           </a:xfrm>
           <a:prstGeom prst="roundRect">
             <a:avLst>
@@ -7050,7 +7050,7 @@
         <p:spPr>
           <a:xfrm>
             <a:off x="6409944" y="2880360"/>
-            <a:ext cx="2103120" cy="1005840"/>
+            <a:ext cx="2103120" cy="1188720"/>
           </a:xfrm>
           <a:prstGeom prst="rect">
             <a:avLst/>
@@ -7069,7 +7069,7 @@
               </a:lnSpc>
             </a:pPr>
             <a:r>
-              <a:rPr sz="1700" b="0">
+              <a:rPr sz="1600" b="0">
                 <a:solidFill>
                   <a:srgbClr val="F2F5F3"/>
                 </a:solidFill>
@@ -7089,7 +7089,7 @@
         <p:spPr>
           <a:xfrm>
             <a:off x="8951976" y="1920240"/>
-            <a:ext cx="2560320" cy="2103120"/>
+            <a:ext cx="2560320" cy="2286000"/>
           </a:xfrm>
           <a:prstGeom prst="roundRect">
             <a:avLst>
@@ -7176,7 +7176,7 @@
         <p:spPr>
           <a:xfrm>
             <a:off x="9180576" y="2880360"/>
-            <a:ext cx="2103120" cy="1005840"/>
+            <a:ext cx="2103120" cy="1188720"/>
           </a:xfrm>
           <a:prstGeom prst="rect">
             <a:avLst/>
@@ -7195,7 +7195,7 @@
               </a:lnSpc>
             </a:pPr>
             <a:r>
-              <a:rPr sz="1700" b="0">
+              <a:rPr sz="1600" b="0">
                 <a:solidFill>
                   <a:srgbClr val="F2F5F3"/>
                 </a:solidFill>

</xml_diff>